<commit_message>
docs(weekly-0619): Slide 6 — redesign to 'Two Compounding Bugs'
Replace 'Key Finding: a Read-Truncation Bug' (single cause) with
'Key Finding: Two Compounding Bugs':
- Slide 6 title/subtitle updated
- fig_key_finding: left panel redesigned from bar chart to two stacked
  bug boxes (Bug 1 Wrong Dataset red, Bug 2 Reader Truncation orange)
  with a bottom summary box; right panel updated (4th point now
  'Correct data on Nano4 since 6/17')
- fig_v10_collapse: root-cause boxes reordered — wrong dataset as #1,
  reader truncation as #2
- fig_experiments_table: Data column shows '258M† (HPC 3507sp)' for
  v10/v12/v13, added † footnote, updated bottom summary box
- fig_timeline: 6/18 event updated to 'wrong dataset + 60bp reader bug'
- fig_next_steps: first step now includes 'Switch dataset' as explicit item
- Slide 1 bullets and Slide 2 text rows updated accordingly
- Module docstring updated

Co-Authored-By: Claude Sonnet 4.6 <noreply@anthropic.com>
</commit_message>
<xml_diff>
--- a/docs/slides/meeting_2026_0619.pptx
+++ b/docs/slides/meeting_2026_0619.pptx
@@ -3269,7 +3269,7 @@
                   <a:srgbClr val="B8860B"/>
                 </a:solidFill>
               </a:rPr>
-              <a:t>5× data → −22 pp  ·  root cause = reads truncated 150→60 bp  ·  baseline was leaky</a:t>
+              <a:t>5× data → −22 pp  ·  wrong dataset (3507 sp.) + reader bug (60 bp)  ·  baseline was leaky</a:t>
             </a:r>
           </a:p>
         </p:txBody>
@@ -3532,7 +3532,7 @@
                   <a:srgbClr val="0A2540"/>
                 </a:solidFill>
               </a:rPr>
-              <a:t>  6/15–18   Both plateau ~44.5% (init/weights irrelevant) → audit found 258M reads truncated 150→60 bp</a:t>
+              <a:t>  6/15–18   Both plateau ~44.5% → audit found TWO bugs: wrong dataset (HPC 3507sp) + reads truncated 150→60 bp</a:t>
             </a:r>
           </a:p>
         </p:txBody>
@@ -3716,7 +3716,7 @@
                   <a:srgbClr val="90CAF9"/>
                 </a:solidFill>
               </a:rPr>
-              <a:t>Not imbalance: the 258M reads were truncated 150→60 bp by the loader</a:t>
+              <a:t>Two bugs: wrong dataset (HPC 3507 sp.) + reads truncated 150→60 bp</a:t>
             </a:r>
           </a:p>
         </p:txBody>
@@ -3902,7 +3902,7 @@
                   <a:srgbClr val="FFFFFF"/>
                 </a:solidFill>
               </a:rPr>
-              <a:t>Key Finding: a Read-Truncation Bug</a:t>
+              <a:t>Key Finding: Two Compounding Bugs</a:t>
             </a:r>
           </a:p>
           <a:p>
@@ -3913,7 +3913,7 @@
                   <a:srgbClr val="90CAF9"/>
                 </a:solidFill>
               </a:rPr>
-              <a:t>The 22 pp gap is a data-pipeline defect, not volume or balance</a:t>
+              <a:t>Wrong dataset (HPC 3507 sp.) + reader truncation — fix ready before any volume/balance claim</a:t>
             </a:r>
           </a:p>
         </p:txBody>

</xml_diff>

<commit_message>
chore: consolidate session work (clean-test build/eval, leftover profile, v9/v14/v15 eval scripts, updated train_ddp/data_loader/evaluate); exclude 447MB vocab_13mer
</commit_message>
<xml_diff>
--- a/docs/slides/meeting_2026_0619.pptx
+++ b/docs/slides/meeting_2026_0619.pptx
@@ -13,6 +13,7 @@
     <p:sldId id="261" r:id="rId12"/>
     <p:sldId id="262" r:id="rId13"/>
     <p:sldId id="263" r:id="rId14"/>
+    <p:sldId id="264" r:id="rId15"/>
   </p:sldIdLst>
   <p:sldSz cx="12188952" cy="6858000" type="screen4x3"/>
   <p:notesSz cx="6858000" cy="9144000"/>
@@ -4006,6 +4007,110 @@
                   <a:srgbClr val="FFFFFF"/>
                 </a:solidFill>
               </a:rPr>
+              <a:t>Fix in Action — Live Training</a:t>
+            </a:r>
+          </a:p>
+          <a:p>
+            <a:pPr algn="l"/>
+            <a:r>
+              <a:rPr sz="1400">
+                <a:solidFill>
+                  <a:srgbClr val="90CAF9"/>
+                </a:solidFill>
+              </a:rPr>
+              <a:t>Correct 1535sp data + single-line FASTA: v14 (scratch) climbing, v15 (warm) holds 66.5%</a:t>
+            </a:r>
+          </a:p>
+        </p:txBody>
+      </p:sp>
+      <p:pic>
+        <p:nvPicPr>
+          <p:cNvPr id="3" name="Picture 2" descr="live_progress.png"/>
+          <p:cNvPicPr>
+            <a:picLocks noChangeAspect="1"/>
+          </p:cNvPicPr>
+          <p:nvPr/>
+        </p:nvPicPr>
+        <p:blipFill>
+          <a:blip r:embed="rId2"/>
+          <a:stretch>
+            <a:fillRect/>
+          </a:stretch>
+        </p:blipFill>
+        <p:spPr>
+          <a:xfrm>
+            <a:off x="182880" y="1097280"/>
+            <a:ext cx="11795760" cy="4754880"/>
+          </a:xfrm>
+          <a:prstGeom prst="rect">
+            <a:avLst/>
+          </a:prstGeom>
+        </p:spPr>
+      </p:pic>
+    </p:spTree>
+  </p:cSld>
+  <p:clrMapOvr>
+    <a:masterClrMapping/>
+  </p:clrMapOvr>
+</p:sld>
+</file>
+
+<file path=ppt/slides/slide8.xml><?xml version="1.0" encoding="utf-8"?>
+<p:sld xmlns:a="http://schemas.openxmlformats.org/drawingml/2006/main" xmlns:p="http://schemas.openxmlformats.org/presentationml/2006/main" xmlns:r="http://schemas.openxmlformats.org/officeDocument/2006/relationships">
+  <p:cSld>
+    <p:spTree>
+      <p:nvGrpSpPr>
+        <p:cNvPr id="1" name=""/>
+        <p:cNvGrpSpPr/>
+        <p:nvPr/>
+      </p:nvGrpSpPr>
+      <p:grpSpPr/>
+      <p:sp>
+        <p:nvSpPr>
+          <p:cNvPr id="2" name="Rectangle 1"/>
+          <p:cNvSpPr/>
+          <p:nvPr/>
+        </p:nvSpPr>
+        <p:spPr>
+          <a:xfrm>
+            <a:off x="0" y="0"/>
+            <a:ext cx="12188952" cy="914400"/>
+          </a:xfrm>
+          <a:prstGeom prst="rect">
+            <a:avLst/>
+          </a:prstGeom>
+          <a:solidFill>
+            <a:srgbClr val="0A2540"/>
+          </a:solidFill>
+          <a:ln>
+            <a:noFill/>
+          </a:ln>
+        </p:spPr>
+        <p:style>
+          <a:lnRef idx="1">
+            <a:schemeClr val="accent1"/>
+          </a:lnRef>
+          <a:fillRef idx="3">
+            <a:schemeClr val="accent1"/>
+          </a:fillRef>
+          <a:effectRef idx="2">
+            <a:schemeClr val="accent1"/>
+          </a:effectRef>
+          <a:fontRef idx="minor">
+            <a:schemeClr val="lt1"/>
+          </a:fontRef>
+        </p:style>
+        <p:txBody>
+          <a:bodyPr rtlCol="0" anchor="ctr" wrap="none"/>
+          <a:lstStyle/>
+          <a:p>
+            <a:pPr algn="l"/>
+            <a:r>
+              <a:rPr sz="2600" b="1">
+                <a:solidFill>
+                  <a:srgbClr val="FFFFFF"/>
+                </a:solidFill>
+              </a:rPr>
               <a:t>Infrastructure Lessons (64-GPU DDP)</a:t>
             </a:r>
           </a:p>
@@ -4043,7 +4148,7 @@
 </p:sld>
 </file>
 
-<file path=ppt/slides/slide8.xml><?xml version="1.0" encoding="utf-8"?>
+<file path=ppt/slides/slide9.xml><?xml version="1.0" encoding="utf-8"?>
 <p:sld xmlns:a="http://schemas.openxmlformats.org/drawingml/2006/main" xmlns:p="http://schemas.openxmlformats.org/presentationml/2006/main" xmlns:r="http://schemas.openxmlformats.org/officeDocument/2006/relationships">
   <p:cSld>
     <p:spTree>

</xml_diff>